<commit_message>
Add source credits to guides and downloads; link Kagan resources without reproducing templates
</commit_message>
<xml_diff>
--- a/retrieval-because-but-so-template.pptx
+++ b/retrieval-because-but-so-template.pptx
@@ -2,13 +2,13 @@
 <file path=ppt/presentation.xml><?xml version="1.0" encoding="utf-8"?>
 <p:presentation xmlns:p="http://schemas.openxmlformats.org/presentationml/2006/main">
   <p:sldMasterIdLst>
-    <p:sldMasterId xmlns:r="http://schemas.openxmlformats.org/officeDocument/2006/relationships" id="2147483648" r:id="R8164062e0f0045da"/>
+    <p:sldMasterId xmlns:r="http://schemas.openxmlformats.org/officeDocument/2006/relationships" id="2147483648" r:id="R7701a5989a04420c"/>
   </p:sldMasterIdLst>
   <p:notesMasterIdLst>
-    <p:notesMasterId xmlns:r="http://schemas.openxmlformats.org/officeDocument/2006/relationships" r:id="R2227c20da9ab4c2c"/>
+    <p:notesMasterId xmlns:r="http://schemas.openxmlformats.org/officeDocument/2006/relationships" r:id="R43b076c457764b1f"/>
   </p:notesMasterIdLst>
   <p:sldIdLst>
-    <p:sldId xmlns:r="http://schemas.openxmlformats.org/officeDocument/2006/relationships" id="256" r:id="Rd7beda09b7cc44e6"/>
+    <p:sldId xmlns:r="http://schemas.openxmlformats.org/officeDocument/2006/relationships" id="256" r:id="Re6d7986810a949d4"/>
   </p:sldIdLst>
   <p:sldSz cx="12192000" cy="6858000"/>
   <p:notesSz cx="6858000" cy="9144000"/>
@@ -455,6 +455,66 @@
               <a:t>For bingo, use your own checked clues. For loop cards, ensure each answer matches the previous card and the last question closes the loop. For card activities, print and cut the cards, keeping target words and answers hidden from the respondent. For cloze recall, use the same passage with progressively more gaps.</a:t>
             </a:r>
           </a:p>
+          <a:p xmlns:a="http://schemas.openxmlformats.org/drawingml/2006/main">
+            <a:r>
+              <a:t/>
+            </a:r>
+          </a:p>
+          <a:p xmlns:a="http://schemas.openxmlformats.org/drawingml/2006/main">
+            <a:r>
+              <a:t>SOURCE AND ACKNOWLEDGEMENT</a:t>
+            </a:r>
+          </a:p>
+          <a:p xmlns:a="http://schemas.openxmlformats.org/drawingml/2006/main">
+            <a:r>
+              <a:t/>
+            </a:r>
+          </a:p>
+          <a:p xmlns:a="http://schemas.openxmlformats.org/drawingml/2006/main">
+            <a:r>
+              <a:t>Judith C. Hochman &amp; Natalie Wexler — The Writing Revolution; Bradford Research School adaptation</a:t>
+            </a:r>
+          </a:p>
+          <a:p xmlns:a="http://schemas.openxmlformats.org/drawingml/2006/main">
+            <a:r>
+              <a:t/>
+            </a:r>
+          </a:p>
+          <a:p xmlns:a="http://schemas.openxmlformats.org/drawingml/2006/main">
+            <a:r>
+              <a:t>https://researchschool.org.uk/bradford/news/retrieval-practice-higher-order-thinking</a:t>
+            </a:r>
+          </a:p>
+          <a:p xmlns:a="http://schemas.openxmlformats.org/drawingml/2006/main">
+            <a:r>
+              <a:t/>
+            </a:r>
+          </a:p>
+          <a:p xmlns:a="http://schemas.openxmlformats.org/drawingml/2006/main">
+            <a:r>
+              <a:t>The because/but/so writing routine is associated with Hochman and Wexler’s The Writing Revolution. Bradford Research School describes adapting it for retrieval and elaboration. This guide follows that combined purpose.</a:t>
+            </a:r>
+          </a:p>
+          <a:p xmlns:a="http://schemas.openxmlformats.org/drawingml/2006/main">
+            <a:r>
+              <a:t/>
+            </a:r>
+          </a:p>
+          <a:p xmlns:a="http://schemas.openxmlformats.org/drawingml/2006/main">
+            <a:r>
+              <a:t>Independent classroom adaptation; the source retains its own rights.</a:t>
+            </a:r>
+          </a:p>
+          <a:p xmlns:a="http://schemas.openxmlformats.org/drawingml/2006/main">
+            <a:r>
+              <a:t/>
+            </a:r>
+          </a:p>
+          <a:p xmlns:a="http://schemas.openxmlformats.org/drawingml/2006/main">
+            <a:r>
+              <a:t>Full guide: https://tnt-teaching-tools.github.io/retrieval-toolkit/retrieval-because-but-so.html</a:t>
+            </a:r>
+          </a:p>
         </p:txBody>
       </p:sp>
       <p:sp>
@@ -499,7 +559,7 @@
           <p:cNvPr id="4" name="Accent rule">
             <a:extLst xmlns:a="http://schemas.openxmlformats.org/drawingml/2006/main">
               <a:ext uri="{FF2B5EF4-FFF2-40B4-BE49-F238E27FC236}">
-                <a16:creationId xmlns:a16="http://schemas.microsoft.com/office/drawing/2014/main" id="{222C2750-C44C-4D0E-A04C-9769F2AAAEBF}"/>
+                <a16:creationId xmlns:a16="http://schemas.microsoft.com/office/drawing/2014/main" id="{27242F87-905B-4F2B-BE1F-936977E455DD}"/>
               </a:ext>
             </a:extLst>
           </p:cNvPr>
@@ -530,7 +590,7 @@
           <p:cNvPr id="2" name="Title">
             <a:extLst xmlns:a="http://schemas.openxmlformats.org/drawingml/2006/main">
               <a:ext uri="{FF2B5EF4-FFF2-40B4-BE49-F238E27FC236}">
-                <a16:creationId xmlns:a16="http://schemas.microsoft.com/office/drawing/2014/main" id="{84D5C338-599A-41A1-BAA1-31A6AD051BAC}"/>
+                <a16:creationId xmlns:a16="http://schemas.microsoft.com/office/drawing/2014/main" id="{4BD98E97-4E52-434B-A381-A4273309CA01}"/>
               </a:ext>
             </a:extLst>
           </p:cNvPr>
@@ -571,6 +631,7 @@
                 <a:spcPts val="0"/>
               </a:spcAft>
               <a:buNone/>
+              <a:defRPr/>
             </a:lvl1pPr>
             <a:lvl2pPr marL="0" indent="0">
               <a:lnSpc>
@@ -583,6 +644,7 @@
                 <a:spcPts val="0"/>
               </a:spcAft>
               <a:buNone/>
+              <a:defRPr/>
             </a:lvl2pPr>
             <a:lvl3pPr marL="0" indent="0">
               <a:lnSpc>
@@ -595,6 +657,7 @@
                 <a:spcPts val="0"/>
               </a:spcAft>
               <a:buNone/>
+              <a:defRPr/>
             </a:lvl3pPr>
             <a:lvl4pPr marL="0" indent="0">
               <a:lnSpc>
@@ -607,6 +670,7 @@
                 <a:spcPts val="0"/>
               </a:spcAft>
               <a:buNone/>
+              <a:defRPr/>
             </a:lvl4pPr>
             <a:lvl5pPr marL="0" indent="0">
               <a:lnSpc>
@@ -619,6 +683,7 @@
                 <a:spcPts val="0"/>
               </a:spcAft>
               <a:buNone/>
+              <a:defRPr/>
             </a:lvl5pPr>
             <a:lvl6pPr marL="0" indent="0">
               <a:lnSpc>
@@ -631,6 +696,7 @@
                 <a:spcPts val="0"/>
               </a:spcAft>
               <a:buNone/>
+              <a:defRPr/>
             </a:lvl6pPr>
             <a:lvl7pPr marL="0" indent="0">
               <a:lnSpc>
@@ -643,6 +709,7 @@
                 <a:spcPts val="0"/>
               </a:spcAft>
               <a:buNone/>
+              <a:defRPr/>
             </a:lvl7pPr>
             <a:lvl8pPr marL="0" indent="0">
               <a:lnSpc>
@@ -655,6 +722,7 @@
                 <a:spcPts val="0"/>
               </a:spcAft>
               <a:buNone/>
+              <a:defRPr/>
             </a:lvl8pPr>
             <a:lvl9pPr marL="0" indent="0">
               <a:lnSpc>
@@ -667,6 +735,7 @@
                 <a:spcPts val="0"/>
               </a:spcAft>
               <a:buNone/>
+              <a:defRPr/>
             </a:lvl9pPr>
           </a:lstStyle>
           <a:p xmlns:a="http://schemas.openxmlformats.org/drawingml/2006/main"/>
@@ -677,7 +746,7 @@
           <p:cNvPr id="3" name="Subtitle">
             <a:extLst xmlns:a="http://schemas.openxmlformats.org/drawingml/2006/main">
               <a:ext uri="{FF2B5EF4-FFF2-40B4-BE49-F238E27FC236}">
-                <a16:creationId xmlns:a16="http://schemas.microsoft.com/office/drawing/2014/main" id="{C1FA7EDA-864C-4F0F-A36D-F8E4632B50A1}"/>
+                <a16:creationId xmlns:a16="http://schemas.microsoft.com/office/drawing/2014/main" id="{5E35D7FD-72FE-468E-89F4-FA07C55A5493}"/>
               </a:ext>
             </a:extLst>
           </p:cNvPr>
@@ -718,6 +787,7 @@
                 <a:spcPts val="0"/>
               </a:spcAft>
               <a:buNone/>
+              <a:defRPr/>
             </a:lvl1pPr>
             <a:lvl2pPr marL="0" indent="0">
               <a:lnSpc>
@@ -730,6 +800,7 @@
                 <a:spcPts val="0"/>
               </a:spcAft>
               <a:buNone/>
+              <a:defRPr/>
             </a:lvl2pPr>
             <a:lvl3pPr marL="0" indent="0">
               <a:lnSpc>
@@ -742,6 +813,7 @@
                 <a:spcPts val="0"/>
               </a:spcAft>
               <a:buNone/>
+              <a:defRPr/>
             </a:lvl3pPr>
             <a:lvl4pPr marL="0" indent="0">
               <a:lnSpc>
@@ -754,6 +826,7 @@
                 <a:spcPts val="0"/>
               </a:spcAft>
               <a:buNone/>
+              <a:defRPr/>
             </a:lvl4pPr>
             <a:lvl5pPr marL="0" indent="0">
               <a:lnSpc>
@@ -766,6 +839,7 @@
                 <a:spcPts val="0"/>
               </a:spcAft>
               <a:buNone/>
+              <a:defRPr/>
             </a:lvl5pPr>
             <a:lvl6pPr marL="0" indent="0">
               <a:lnSpc>
@@ -778,6 +852,7 @@
                 <a:spcPts val="0"/>
               </a:spcAft>
               <a:buNone/>
+              <a:defRPr/>
             </a:lvl6pPr>
             <a:lvl7pPr marL="0" indent="0">
               <a:lnSpc>
@@ -790,6 +865,7 @@
                 <a:spcPts val="0"/>
               </a:spcAft>
               <a:buNone/>
+              <a:defRPr/>
             </a:lvl7pPr>
             <a:lvl8pPr marL="0" indent="0">
               <a:lnSpc>
@@ -802,6 +878,7 @@
                 <a:spcPts val="0"/>
               </a:spcAft>
               <a:buNone/>
+              <a:defRPr/>
             </a:lvl8pPr>
             <a:lvl9pPr marL="0" indent="0">
               <a:lnSpc>
@@ -814,6 +891,7 @@
                 <a:spcPts val="0"/>
               </a:spcAft>
               <a:buNone/>
+              <a:defRPr/>
             </a:lvl9pPr>
           </a:lstStyle>
           <a:p xmlns:a="http://schemas.openxmlformats.org/drawingml/2006/main"/>
@@ -841,7 +919,7 @@
           <p:cNvPr id="3" name="Accent rule">
             <a:extLst xmlns:a="http://schemas.openxmlformats.org/drawingml/2006/main">
               <a:ext uri="{FF2B5EF4-FFF2-40B4-BE49-F238E27FC236}">
-                <a16:creationId xmlns:a16="http://schemas.microsoft.com/office/drawing/2014/main" id="{21F85C4D-D1D7-42C7-882D-F186C9ED5F29}"/>
+                <a16:creationId xmlns:a16="http://schemas.microsoft.com/office/drawing/2014/main" id="{A1F5EC98-B332-4C60-AC92-4C0893B743E9}"/>
               </a:ext>
             </a:extLst>
           </p:cNvPr>
@@ -872,7 +950,7 @@
           <p:cNvPr id="2" name="Section title">
             <a:extLst xmlns:a="http://schemas.openxmlformats.org/drawingml/2006/main">
               <a:ext uri="{FF2B5EF4-FFF2-40B4-BE49-F238E27FC236}">
-                <a16:creationId xmlns:a16="http://schemas.microsoft.com/office/drawing/2014/main" id="{9A462FAC-5B7E-4FF0-BC43-655FD0D28315}"/>
+                <a16:creationId xmlns:a16="http://schemas.microsoft.com/office/drawing/2014/main" id="{34E22616-78E8-428B-8FFD-BD12554E48CB}"/>
               </a:ext>
             </a:extLst>
           </p:cNvPr>
@@ -913,6 +991,7 @@
                 <a:spcPts val="0"/>
               </a:spcAft>
               <a:buNone/>
+              <a:defRPr/>
             </a:lvl1pPr>
             <a:lvl2pPr marL="0" indent="0">
               <a:lnSpc>
@@ -925,6 +1004,7 @@
                 <a:spcPts val="0"/>
               </a:spcAft>
               <a:buNone/>
+              <a:defRPr/>
             </a:lvl2pPr>
             <a:lvl3pPr marL="0" indent="0">
               <a:lnSpc>
@@ -937,6 +1017,7 @@
                 <a:spcPts val="0"/>
               </a:spcAft>
               <a:buNone/>
+              <a:defRPr/>
             </a:lvl3pPr>
             <a:lvl4pPr marL="0" indent="0">
               <a:lnSpc>
@@ -949,6 +1030,7 @@
                 <a:spcPts val="0"/>
               </a:spcAft>
               <a:buNone/>
+              <a:defRPr/>
             </a:lvl4pPr>
             <a:lvl5pPr marL="0" indent="0">
               <a:lnSpc>
@@ -961,6 +1043,7 @@
                 <a:spcPts val="0"/>
               </a:spcAft>
               <a:buNone/>
+              <a:defRPr/>
             </a:lvl5pPr>
             <a:lvl6pPr marL="0" indent="0">
               <a:lnSpc>
@@ -973,6 +1056,7 @@
                 <a:spcPts val="0"/>
               </a:spcAft>
               <a:buNone/>
+              <a:defRPr/>
             </a:lvl6pPr>
             <a:lvl7pPr marL="0" indent="0">
               <a:lnSpc>
@@ -985,6 +1069,7 @@
                 <a:spcPts val="0"/>
               </a:spcAft>
               <a:buNone/>
+              <a:defRPr/>
             </a:lvl7pPr>
             <a:lvl8pPr marL="0" indent="0">
               <a:lnSpc>
@@ -997,6 +1082,7 @@
                 <a:spcPts val="0"/>
               </a:spcAft>
               <a:buNone/>
+              <a:defRPr/>
             </a:lvl8pPr>
             <a:lvl9pPr marL="0" indent="0">
               <a:lnSpc>
@@ -1009,6 +1095,7 @@
                 <a:spcPts val="0"/>
               </a:spcAft>
               <a:buNone/>
+              <a:defRPr/>
             </a:lvl9pPr>
           </a:lstStyle>
           <a:p xmlns:a="http://schemas.openxmlformats.org/drawingml/2006/main"/>
@@ -1036,7 +1123,7 @@
           <p:cNvPr id="4" name="Accent rule">
             <a:extLst xmlns:a="http://schemas.openxmlformats.org/drawingml/2006/main">
               <a:ext uri="{FF2B5EF4-FFF2-40B4-BE49-F238E27FC236}">
-                <a16:creationId xmlns:a16="http://schemas.microsoft.com/office/drawing/2014/main" id="{F527E3DF-18ED-43AB-AE76-EAA69ACB02E6}"/>
+                <a16:creationId xmlns:a16="http://schemas.microsoft.com/office/drawing/2014/main" id="{D3B05B45-CA06-4DD7-9837-B653E16E4A33}"/>
               </a:ext>
             </a:extLst>
           </p:cNvPr>
@@ -1067,7 +1154,7 @@
           <p:cNvPr id="2" name="Title">
             <a:extLst xmlns:a="http://schemas.openxmlformats.org/drawingml/2006/main">
               <a:ext uri="{FF2B5EF4-FFF2-40B4-BE49-F238E27FC236}">
-                <a16:creationId xmlns:a16="http://schemas.microsoft.com/office/drawing/2014/main" id="{11681F0E-5041-4C1E-BA82-7900957C188A}"/>
+                <a16:creationId xmlns:a16="http://schemas.microsoft.com/office/drawing/2014/main" id="{51483976-C61E-4EEF-B502-520E2337A3E2}"/>
               </a:ext>
             </a:extLst>
           </p:cNvPr>
@@ -1108,6 +1195,7 @@
                 <a:spcPts val="0"/>
               </a:spcAft>
               <a:buNone/>
+              <a:defRPr/>
             </a:lvl1pPr>
             <a:lvl2pPr marL="0" indent="0">
               <a:lnSpc>
@@ -1120,6 +1208,7 @@
                 <a:spcPts val="0"/>
               </a:spcAft>
               <a:buNone/>
+              <a:defRPr/>
             </a:lvl2pPr>
             <a:lvl3pPr marL="0" indent="0">
               <a:lnSpc>
@@ -1132,6 +1221,7 @@
                 <a:spcPts val="0"/>
               </a:spcAft>
               <a:buNone/>
+              <a:defRPr/>
             </a:lvl3pPr>
             <a:lvl4pPr marL="0" indent="0">
               <a:lnSpc>
@@ -1144,6 +1234,7 @@
                 <a:spcPts val="0"/>
               </a:spcAft>
               <a:buNone/>
+              <a:defRPr/>
             </a:lvl4pPr>
             <a:lvl5pPr marL="0" indent="0">
               <a:lnSpc>
@@ -1156,6 +1247,7 @@
                 <a:spcPts val="0"/>
               </a:spcAft>
               <a:buNone/>
+              <a:defRPr/>
             </a:lvl5pPr>
             <a:lvl6pPr marL="0" indent="0">
               <a:lnSpc>
@@ -1168,6 +1260,7 @@
                 <a:spcPts val="0"/>
               </a:spcAft>
               <a:buNone/>
+              <a:defRPr/>
             </a:lvl6pPr>
             <a:lvl7pPr marL="0" indent="0">
               <a:lnSpc>
@@ -1180,6 +1273,7 @@
                 <a:spcPts val="0"/>
               </a:spcAft>
               <a:buNone/>
+              <a:defRPr/>
             </a:lvl7pPr>
             <a:lvl8pPr marL="0" indent="0">
               <a:lnSpc>
@@ -1192,6 +1286,7 @@
                 <a:spcPts val="0"/>
               </a:spcAft>
               <a:buNone/>
+              <a:defRPr/>
             </a:lvl8pPr>
             <a:lvl9pPr marL="0" indent="0">
               <a:lnSpc>
@@ -1204,6 +1299,7 @@
                 <a:spcPts val="0"/>
               </a:spcAft>
               <a:buNone/>
+              <a:defRPr/>
             </a:lvl9pPr>
           </a:lstStyle>
           <a:p xmlns:a="http://schemas.openxmlformats.org/drawingml/2006/main"/>
@@ -1214,7 +1310,7 @@
           <p:cNvPr id="3" name="Body">
             <a:extLst xmlns:a="http://schemas.openxmlformats.org/drawingml/2006/main">
               <a:ext uri="{FF2B5EF4-FFF2-40B4-BE49-F238E27FC236}">
-                <a16:creationId xmlns:a16="http://schemas.microsoft.com/office/drawing/2014/main" id="{65B1D3FD-FABE-4AC4-8B27-F4EA1E1B5964}"/>
+                <a16:creationId xmlns:a16="http://schemas.microsoft.com/office/drawing/2014/main" id="{C8FE5B40-0980-406D-81A3-94B82038F53D}"/>
               </a:ext>
             </a:extLst>
           </p:cNvPr>
@@ -1255,6 +1351,7 @@
                 <a:spcPts val="1200"/>
               </a:spcAft>
               <a:buChar char="•"/>
+              <a:defRPr/>
             </a:lvl1pPr>
             <a:lvl2pPr marL="533400" indent="-228600">
               <a:lnSpc>
@@ -1267,6 +1364,7 @@
                 <a:spcPts val="1200"/>
               </a:spcAft>
               <a:buChar char="•"/>
+              <a:defRPr/>
             </a:lvl2pPr>
             <a:lvl3pPr marL="838200" indent="-228600">
               <a:lnSpc>
@@ -1279,6 +1377,7 @@
                 <a:spcPts val="1200"/>
               </a:spcAft>
               <a:buChar char="•"/>
+              <a:defRPr/>
             </a:lvl3pPr>
             <a:lvl4pPr marL="1143000" indent="-228600">
               <a:lnSpc>
@@ -1291,6 +1390,7 @@
                 <a:spcPts val="1200"/>
               </a:spcAft>
               <a:buChar char="•"/>
+              <a:defRPr/>
             </a:lvl4pPr>
             <a:lvl5pPr marL="1447800" indent="-228600">
               <a:lnSpc>
@@ -1303,6 +1403,7 @@
                 <a:spcPts val="1200"/>
               </a:spcAft>
               <a:buChar char="•"/>
+              <a:defRPr/>
             </a:lvl5pPr>
             <a:lvl6pPr marL="1752600" indent="-228600">
               <a:lnSpc>
@@ -1315,6 +1416,7 @@
                 <a:spcPts val="1200"/>
               </a:spcAft>
               <a:buChar char="•"/>
+              <a:defRPr/>
             </a:lvl6pPr>
             <a:lvl7pPr marL="2057400" indent="-228600">
               <a:lnSpc>
@@ -1327,6 +1429,7 @@
                 <a:spcPts val="1200"/>
               </a:spcAft>
               <a:buChar char="•"/>
+              <a:defRPr/>
             </a:lvl7pPr>
             <a:lvl8pPr marL="2362200" indent="-228600">
               <a:lnSpc>
@@ -1339,6 +1442,7 @@
                 <a:spcPts val="1200"/>
               </a:spcAft>
               <a:buChar char="•"/>
+              <a:defRPr/>
             </a:lvl8pPr>
             <a:lvl9pPr marL="2667000" indent="-228600">
               <a:lnSpc>
@@ -1351,6 +1455,7 @@
                 <a:spcPts val="1200"/>
               </a:spcAft>
               <a:buChar char="•"/>
+              <a:defRPr/>
             </a:lvl9pPr>
           </a:lstStyle>
           <a:p xmlns:a="http://schemas.openxmlformats.org/drawingml/2006/main"/>
@@ -1378,7 +1483,7 @@
           <p:cNvPr id="5" name="Accent rule">
             <a:extLst xmlns:a="http://schemas.openxmlformats.org/drawingml/2006/main">
               <a:ext uri="{FF2B5EF4-FFF2-40B4-BE49-F238E27FC236}">
-                <a16:creationId xmlns:a16="http://schemas.microsoft.com/office/drawing/2014/main" id="{A32DF8FA-C61E-4688-8AE9-76274D48FF0B}"/>
+                <a16:creationId xmlns:a16="http://schemas.microsoft.com/office/drawing/2014/main" id="{534DB576-6DD9-4643-9F19-1ECA6198119B}"/>
               </a:ext>
             </a:extLst>
           </p:cNvPr>
@@ -1409,7 +1514,7 @@
           <p:cNvPr id="2" name="Title">
             <a:extLst xmlns:a="http://schemas.openxmlformats.org/drawingml/2006/main">
               <a:ext uri="{FF2B5EF4-FFF2-40B4-BE49-F238E27FC236}">
-                <a16:creationId xmlns:a16="http://schemas.microsoft.com/office/drawing/2014/main" id="{10084E88-D1B1-411E-B2D1-E5E152648B6A}"/>
+                <a16:creationId xmlns:a16="http://schemas.microsoft.com/office/drawing/2014/main" id="{8381C995-7CFE-47E1-90C9-D2BFAC9DC3EB}"/>
               </a:ext>
             </a:extLst>
           </p:cNvPr>
@@ -1450,6 +1555,7 @@
                 <a:spcPts val="0"/>
               </a:spcAft>
               <a:buNone/>
+              <a:defRPr/>
             </a:lvl1pPr>
             <a:lvl2pPr marL="0" indent="0">
               <a:lnSpc>
@@ -1462,6 +1568,7 @@
                 <a:spcPts val="0"/>
               </a:spcAft>
               <a:buNone/>
+              <a:defRPr/>
             </a:lvl2pPr>
             <a:lvl3pPr marL="0" indent="0">
               <a:lnSpc>
@@ -1474,6 +1581,7 @@
                 <a:spcPts val="0"/>
               </a:spcAft>
               <a:buNone/>
+              <a:defRPr/>
             </a:lvl3pPr>
             <a:lvl4pPr marL="0" indent="0">
               <a:lnSpc>
@@ -1486,6 +1594,7 @@
                 <a:spcPts val="0"/>
               </a:spcAft>
               <a:buNone/>
+              <a:defRPr/>
             </a:lvl4pPr>
             <a:lvl5pPr marL="0" indent="0">
               <a:lnSpc>
@@ -1498,6 +1607,7 @@
                 <a:spcPts val="0"/>
               </a:spcAft>
               <a:buNone/>
+              <a:defRPr/>
             </a:lvl5pPr>
             <a:lvl6pPr marL="0" indent="0">
               <a:lnSpc>
@@ -1510,6 +1620,7 @@
                 <a:spcPts val="0"/>
               </a:spcAft>
               <a:buNone/>
+              <a:defRPr/>
             </a:lvl6pPr>
             <a:lvl7pPr marL="0" indent="0">
               <a:lnSpc>
@@ -1522,6 +1633,7 @@
                 <a:spcPts val="0"/>
               </a:spcAft>
               <a:buNone/>
+              <a:defRPr/>
             </a:lvl7pPr>
             <a:lvl8pPr marL="0" indent="0">
               <a:lnSpc>
@@ -1534,6 +1646,7 @@
                 <a:spcPts val="0"/>
               </a:spcAft>
               <a:buNone/>
+              <a:defRPr/>
             </a:lvl8pPr>
             <a:lvl9pPr marL="0" indent="0">
               <a:lnSpc>
@@ -1546,6 +1659,7 @@
                 <a:spcPts val="0"/>
               </a:spcAft>
               <a:buNone/>
+              <a:defRPr/>
             </a:lvl9pPr>
           </a:lstStyle>
           <a:p xmlns:a="http://schemas.openxmlformats.org/drawingml/2006/main"/>
@@ -1556,7 +1670,7 @@
           <p:cNvPr id="3" name="Left column">
             <a:extLst xmlns:a="http://schemas.openxmlformats.org/drawingml/2006/main">
               <a:ext uri="{FF2B5EF4-FFF2-40B4-BE49-F238E27FC236}">
-                <a16:creationId xmlns:a16="http://schemas.microsoft.com/office/drawing/2014/main" id="{D0F3ED62-35C6-4FD2-A55E-5B703C60EC81}"/>
+                <a16:creationId xmlns:a16="http://schemas.microsoft.com/office/drawing/2014/main" id="{C26002D2-F2C0-45B8-9866-4E6D1490E836}"/>
               </a:ext>
             </a:extLst>
           </p:cNvPr>
@@ -1597,6 +1711,7 @@
                 <a:spcPts val="1200"/>
               </a:spcAft>
               <a:buChar char="•"/>
+              <a:defRPr/>
             </a:lvl1pPr>
             <a:lvl2pPr marL="533400" indent="-228600">
               <a:lnSpc>
@@ -1609,6 +1724,7 @@
                 <a:spcPts val="1200"/>
               </a:spcAft>
               <a:buChar char="•"/>
+              <a:defRPr/>
             </a:lvl2pPr>
             <a:lvl3pPr marL="838200" indent="-228600">
               <a:lnSpc>
@@ -1621,6 +1737,7 @@
                 <a:spcPts val="1200"/>
               </a:spcAft>
               <a:buChar char="•"/>
+              <a:defRPr/>
             </a:lvl3pPr>
             <a:lvl4pPr marL="1143000" indent="-228600">
               <a:lnSpc>
@@ -1633,6 +1750,7 @@
                 <a:spcPts val="1200"/>
               </a:spcAft>
               <a:buChar char="•"/>
+              <a:defRPr/>
             </a:lvl4pPr>
             <a:lvl5pPr marL="1447800" indent="-228600">
               <a:lnSpc>
@@ -1645,6 +1763,7 @@
                 <a:spcPts val="1200"/>
               </a:spcAft>
               <a:buChar char="•"/>
+              <a:defRPr/>
             </a:lvl5pPr>
             <a:lvl6pPr marL="1752600" indent="-228600">
               <a:lnSpc>
@@ -1657,6 +1776,7 @@
                 <a:spcPts val="1200"/>
               </a:spcAft>
               <a:buChar char="•"/>
+              <a:defRPr/>
             </a:lvl6pPr>
             <a:lvl7pPr marL="2057400" indent="-228600">
               <a:lnSpc>
@@ -1669,6 +1789,7 @@
                 <a:spcPts val="1200"/>
               </a:spcAft>
               <a:buChar char="•"/>
+              <a:defRPr/>
             </a:lvl7pPr>
             <a:lvl8pPr marL="2362200" indent="-228600">
               <a:lnSpc>
@@ -1681,6 +1802,7 @@
                 <a:spcPts val="1200"/>
               </a:spcAft>
               <a:buChar char="•"/>
+              <a:defRPr/>
             </a:lvl8pPr>
             <a:lvl9pPr marL="2667000" indent="-228600">
               <a:lnSpc>
@@ -1693,6 +1815,7 @@
                 <a:spcPts val="1200"/>
               </a:spcAft>
               <a:buChar char="•"/>
+              <a:defRPr/>
             </a:lvl9pPr>
           </a:lstStyle>
           <a:p xmlns:a="http://schemas.openxmlformats.org/drawingml/2006/main"/>
@@ -1703,7 +1826,7 @@
           <p:cNvPr id="4" name="Right column">
             <a:extLst xmlns:a="http://schemas.openxmlformats.org/drawingml/2006/main">
               <a:ext uri="{FF2B5EF4-FFF2-40B4-BE49-F238E27FC236}">
-                <a16:creationId xmlns:a16="http://schemas.microsoft.com/office/drawing/2014/main" id="{0CEA42E6-72F7-43F1-A4C0-6DDAC698D43F}"/>
+                <a16:creationId xmlns:a16="http://schemas.microsoft.com/office/drawing/2014/main" id="{78F29CD4-FA8F-4BBD-A170-10D797646F57}"/>
               </a:ext>
             </a:extLst>
           </p:cNvPr>
@@ -1744,6 +1867,7 @@
                 <a:spcPts val="1200"/>
               </a:spcAft>
               <a:buChar char="•"/>
+              <a:defRPr/>
             </a:lvl1pPr>
             <a:lvl2pPr marL="533400" indent="-228600">
               <a:lnSpc>
@@ -1756,6 +1880,7 @@
                 <a:spcPts val="1200"/>
               </a:spcAft>
               <a:buChar char="•"/>
+              <a:defRPr/>
             </a:lvl2pPr>
             <a:lvl3pPr marL="838200" indent="-228600">
               <a:lnSpc>
@@ -1768,6 +1893,7 @@
                 <a:spcPts val="1200"/>
               </a:spcAft>
               <a:buChar char="•"/>
+              <a:defRPr/>
             </a:lvl3pPr>
             <a:lvl4pPr marL="1143000" indent="-228600">
               <a:lnSpc>
@@ -1780,6 +1906,7 @@
                 <a:spcPts val="1200"/>
               </a:spcAft>
               <a:buChar char="•"/>
+              <a:defRPr/>
             </a:lvl4pPr>
             <a:lvl5pPr marL="1447800" indent="-228600">
               <a:lnSpc>
@@ -1792,6 +1919,7 @@
                 <a:spcPts val="1200"/>
               </a:spcAft>
               <a:buChar char="•"/>
+              <a:defRPr/>
             </a:lvl5pPr>
             <a:lvl6pPr marL="1752600" indent="-228600">
               <a:lnSpc>
@@ -1804,6 +1932,7 @@
                 <a:spcPts val="1200"/>
               </a:spcAft>
               <a:buChar char="•"/>
+              <a:defRPr/>
             </a:lvl6pPr>
             <a:lvl7pPr marL="2057400" indent="-228600">
               <a:lnSpc>
@@ -1816,6 +1945,7 @@
                 <a:spcPts val="1200"/>
               </a:spcAft>
               <a:buChar char="•"/>
+              <a:defRPr/>
             </a:lvl7pPr>
             <a:lvl8pPr marL="2362200" indent="-228600">
               <a:lnSpc>
@@ -1828,6 +1958,7 @@
                 <a:spcPts val="1200"/>
               </a:spcAft>
               <a:buChar char="•"/>
+              <a:defRPr/>
             </a:lvl8pPr>
             <a:lvl9pPr marL="2667000" indent="-228600">
               <a:lnSpc>
@@ -1840,6 +1971,7 @@
                 <a:spcPts val="1200"/>
               </a:spcAft>
               <a:buChar char="•"/>
+              <a:defRPr/>
             </a:lvl9pPr>
           </a:lstStyle>
           <a:p xmlns:a="http://schemas.openxmlformats.org/drawingml/2006/main"/>
@@ -1867,7 +1999,7 @@
           <p:cNvPr id="4" name="Accent rule">
             <a:extLst xmlns:a="http://schemas.openxmlformats.org/drawingml/2006/main">
               <a:ext uri="{FF2B5EF4-FFF2-40B4-BE49-F238E27FC236}">
-                <a16:creationId xmlns:a16="http://schemas.microsoft.com/office/drawing/2014/main" id="{9AF1FB33-52BC-4A16-B93B-63CC25F85DE9}"/>
+                <a16:creationId xmlns:a16="http://schemas.microsoft.com/office/drawing/2014/main" id="{9E7F561C-5AE5-41A4-81BC-E9E918ECA8C0}"/>
               </a:ext>
             </a:extLst>
           </p:cNvPr>
@@ -1898,7 +2030,7 @@
           <p:cNvPr id="2" name="Title">
             <a:extLst xmlns:a="http://schemas.openxmlformats.org/drawingml/2006/main">
               <a:ext uri="{FF2B5EF4-FFF2-40B4-BE49-F238E27FC236}">
-                <a16:creationId xmlns:a16="http://schemas.microsoft.com/office/drawing/2014/main" id="{BA95D56E-0C2D-448E-AB9C-5DEEB78FDFCA}"/>
+                <a16:creationId xmlns:a16="http://schemas.microsoft.com/office/drawing/2014/main" id="{54A37B16-7265-48FE-B92D-7845B1049CF6}"/>
               </a:ext>
             </a:extLst>
           </p:cNvPr>
@@ -1939,6 +2071,7 @@
                 <a:spcPts val="0"/>
               </a:spcAft>
               <a:buNone/>
+              <a:defRPr/>
             </a:lvl1pPr>
             <a:lvl2pPr marL="0" indent="0">
               <a:lnSpc>
@@ -1951,6 +2084,7 @@
                 <a:spcPts val="0"/>
               </a:spcAft>
               <a:buNone/>
+              <a:defRPr/>
             </a:lvl2pPr>
             <a:lvl3pPr marL="0" indent="0">
               <a:lnSpc>
@@ -1963,6 +2097,7 @@
                 <a:spcPts val="0"/>
               </a:spcAft>
               <a:buNone/>
+              <a:defRPr/>
             </a:lvl3pPr>
             <a:lvl4pPr marL="0" indent="0">
               <a:lnSpc>
@@ -1975,6 +2110,7 @@
                 <a:spcPts val="0"/>
               </a:spcAft>
               <a:buNone/>
+              <a:defRPr/>
             </a:lvl4pPr>
             <a:lvl5pPr marL="0" indent="0">
               <a:lnSpc>
@@ -1987,6 +2123,7 @@
                 <a:spcPts val="0"/>
               </a:spcAft>
               <a:buNone/>
+              <a:defRPr/>
             </a:lvl5pPr>
             <a:lvl6pPr marL="0" indent="0">
               <a:lnSpc>
@@ -1999,6 +2136,7 @@
                 <a:spcPts val="0"/>
               </a:spcAft>
               <a:buNone/>
+              <a:defRPr/>
             </a:lvl6pPr>
             <a:lvl7pPr marL="0" indent="0">
               <a:lnSpc>
@@ -2011,6 +2149,7 @@
                 <a:spcPts val="0"/>
               </a:spcAft>
               <a:buNone/>
+              <a:defRPr/>
             </a:lvl7pPr>
             <a:lvl8pPr marL="0" indent="0">
               <a:lnSpc>
@@ -2023,6 +2162,7 @@
                 <a:spcPts val="0"/>
               </a:spcAft>
               <a:buNone/>
+              <a:defRPr/>
             </a:lvl8pPr>
             <a:lvl9pPr marL="0" indent="0">
               <a:lnSpc>
@@ -2035,6 +2175,7 @@
                 <a:spcPts val="0"/>
               </a:spcAft>
               <a:buNone/>
+              <a:defRPr/>
             </a:lvl9pPr>
           </a:lstStyle>
           <a:p xmlns:a="http://schemas.openxmlformats.org/drawingml/2006/main"/>
@@ -2045,7 +2186,7 @@
           <p:cNvPr id="3" name="Left column">
             <a:extLst xmlns:a="http://schemas.openxmlformats.org/drawingml/2006/main">
               <a:ext uri="{FF2B5EF4-FFF2-40B4-BE49-F238E27FC236}">
-                <a16:creationId xmlns:a16="http://schemas.microsoft.com/office/drawing/2014/main" id="{D932A652-EB5E-44BD-94BE-4C97BB1645DC}"/>
+                <a16:creationId xmlns:a16="http://schemas.microsoft.com/office/drawing/2014/main" id="{B6AC10D3-0834-4999-8F7C-78A7D20DCF89}"/>
               </a:ext>
             </a:extLst>
           </p:cNvPr>
@@ -2086,6 +2227,7 @@
                 <a:spcPts val="1200"/>
               </a:spcAft>
               <a:buChar char="•"/>
+              <a:defRPr/>
             </a:lvl1pPr>
             <a:lvl2pPr marL="533400" indent="-228600">
               <a:lnSpc>
@@ -2098,6 +2240,7 @@
                 <a:spcPts val="1200"/>
               </a:spcAft>
               <a:buChar char="•"/>
+              <a:defRPr/>
             </a:lvl2pPr>
             <a:lvl3pPr marL="838200" indent="-228600">
               <a:lnSpc>
@@ -2110,6 +2253,7 @@
                 <a:spcPts val="1200"/>
               </a:spcAft>
               <a:buChar char="•"/>
+              <a:defRPr/>
             </a:lvl3pPr>
             <a:lvl4pPr marL="1143000" indent="-228600">
               <a:lnSpc>
@@ -2122,6 +2266,7 @@
                 <a:spcPts val="1200"/>
               </a:spcAft>
               <a:buChar char="•"/>
+              <a:defRPr/>
             </a:lvl4pPr>
             <a:lvl5pPr marL="1447800" indent="-228600">
               <a:lnSpc>
@@ -2134,6 +2279,7 @@
                 <a:spcPts val="1200"/>
               </a:spcAft>
               <a:buChar char="•"/>
+              <a:defRPr/>
             </a:lvl5pPr>
             <a:lvl6pPr marL="1752600" indent="-228600">
               <a:lnSpc>
@@ -2146,6 +2292,7 @@
                 <a:spcPts val="1200"/>
               </a:spcAft>
               <a:buChar char="•"/>
+              <a:defRPr/>
             </a:lvl6pPr>
             <a:lvl7pPr marL="2057400" indent="-228600">
               <a:lnSpc>
@@ -2158,6 +2305,7 @@
                 <a:spcPts val="1200"/>
               </a:spcAft>
               <a:buChar char="•"/>
+              <a:defRPr/>
             </a:lvl7pPr>
             <a:lvl8pPr marL="2362200" indent="-228600">
               <a:lnSpc>
@@ -2170,6 +2318,7 @@
                 <a:spcPts val="1200"/>
               </a:spcAft>
               <a:buChar char="•"/>
+              <a:defRPr/>
             </a:lvl8pPr>
             <a:lvl9pPr marL="2667000" indent="-228600">
               <a:lnSpc>
@@ -2182,6 +2331,7 @@
                 <a:spcPts val="1200"/>
               </a:spcAft>
               <a:buChar char="•"/>
+              <a:defRPr/>
             </a:lvl9pPr>
           </a:lstStyle>
           <a:p xmlns:a="http://schemas.openxmlformats.org/drawingml/2006/main"/>
@@ -2230,12 +2380,12 @@
   </p:cSld>
   <p:clrMap bg1="lt1" tx1="dk1" bg2="lt2" tx2="dk2" accent1="accent1" accent2="accent2" accent3="accent3" accent4="accent4" accent5="accent5" accent6="accent6" hlink="hlink" folHlink="folHlink"/>
   <p:sldLayoutIdLst>
-    <p:sldLayoutId xmlns:r="http://schemas.openxmlformats.org/officeDocument/2006/relationships" id="2147483649" r:id="Rb235bdf56b064645"/>
-    <p:sldLayoutId xmlns:r="http://schemas.openxmlformats.org/officeDocument/2006/relationships" id="2147483650" r:id="Rc52ae45415ac4da8"/>
-    <p:sldLayoutId xmlns:r="http://schemas.openxmlformats.org/officeDocument/2006/relationships" id="2147483651" r:id="Rfec10a63e0e94698"/>
-    <p:sldLayoutId xmlns:r="http://schemas.openxmlformats.org/officeDocument/2006/relationships" id="2147483652" r:id="R751943604e704610"/>
-    <p:sldLayoutId xmlns:r="http://schemas.openxmlformats.org/officeDocument/2006/relationships" id="2147483653" r:id="R023fcadfcef8479d"/>
-    <p:sldLayoutId xmlns:r="http://schemas.openxmlformats.org/officeDocument/2006/relationships" id="2147483654" r:id="Rb460c36418614c99"/>
+    <p:sldLayoutId xmlns:r="http://schemas.openxmlformats.org/officeDocument/2006/relationships" id="2147483649" r:id="Rc995089eeb3d450e"/>
+    <p:sldLayoutId xmlns:r="http://schemas.openxmlformats.org/officeDocument/2006/relationships" id="2147483650" r:id="R742ca67a4cc84073"/>
+    <p:sldLayoutId xmlns:r="http://schemas.openxmlformats.org/officeDocument/2006/relationships" id="2147483651" r:id="R0165bc4f98e3404f"/>
+    <p:sldLayoutId xmlns:r="http://schemas.openxmlformats.org/officeDocument/2006/relationships" id="2147483652" r:id="R7994c0ef8b254131"/>
+    <p:sldLayoutId xmlns:r="http://schemas.openxmlformats.org/officeDocument/2006/relationships" id="2147483653" r:id="Rd2eb9a2bb4644401"/>
+    <p:sldLayoutId xmlns:r="http://schemas.openxmlformats.org/officeDocument/2006/relationships" id="2147483654" r:id="R23d5f28517e64e48"/>
   </p:sldLayoutIdLst>
   <p:txStyles>
     <p:titleStyle>
@@ -2786,7 +2936,7 @@
           <p:cNvPr id="15" name="">
             <a:extLst xmlns:a="http://schemas.openxmlformats.org/drawingml/2006/main">
               <a:ext uri="{FF2B5EF4-FFF2-40B4-BE49-F238E27FC236}">
-                <a16:creationId xmlns:a16="http://schemas.microsoft.com/office/drawing/2014/main" id="{342B663A-D907-43DF-BDB7-E44803D2C9C2}"/>
+                <a16:creationId xmlns:a16="http://schemas.microsoft.com/office/drawing/2014/main" id="{0E326838-DFA4-4E10-B573-FED5EAF1EF19}"/>
               </a:ext>
             </a:extLst>
           </p:cNvPr>
@@ -2815,6 +2965,7 @@
           <a:lstStyle xmlns:a="http://schemas.openxmlformats.org/drawingml/2006/main"/>
           <a:p xmlns:a="http://schemas.openxmlformats.org/drawingml/2006/main">
             <a:pPr>
+              <a:buNone/>
               <a:defRPr sz="3300" b="1">
                 <a:solidFill>
                   <a:srgbClr val="263C3A"/>
@@ -2843,7 +2994,7 @@
           <p:cNvPr id="2" name="">
             <a:extLst xmlns:a="http://schemas.openxmlformats.org/drawingml/2006/main">
               <a:ext uri="{FF2B5EF4-FFF2-40B4-BE49-F238E27FC236}">
-                <a16:creationId xmlns:a16="http://schemas.microsoft.com/office/drawing/2014/main" id="{2EFBA2CF-2730-415E-870F-F15B2A554EFD}"/>
+                <a16:creationId xmlns:a16="http://schemas.microsoft.com/office/drawing/2014/main" id="{68471CD8-6A03-4B53-8482-615FF2AD5642}"/>
               </a:ext>
             </a:extLst>
           </p:cNvPr>
@@ -2872,6 +3023,7 @@
           <a:lstStyle xmlns:a="http://schemas.openxmlformats.org/drawingml/2006/main"/>
           <a:p xmlns:a="http://schemas.openxmlformats.org/drawingml/2006/main">
             <a:pPr>
+              <a:buNone/>
               <a:defRPr sz="2175" b="0">
                 <a:solidFill>
                   <a:srgbClr val="687572"/>
@@ -2900,7 +3052,7 @@
           <p:cNvPr id="3" name="">
             <a:extLst xmlns:a="http://schemas.openxmlformats.org/drawingml/2006/main">
               <a:ext uri="{FF2B5EF4-FFF2-40B4-BE49-F238E27FC236}">
-                <a16:creationId xmlns:a16="http://schemas.microsoft.com/office/drawing/2014/main" id="{384E67FC-2EE7-4332-832F-54735FF295CB}"/>
+                <a16:creationId xmlns:a16="http://schemas.microsoft.com/office/drawing/2014/main" id="{5F629484-E54D-483E-A535-07E58BB8FA7D}"/>
               </a:ext>
             </a:extLst>
           </p:cNvPr>
@@ -2930,7 +3082,7 @@
           <p:cNvPr id="4" name="">
             <a:extLst xmlns:a="http://schemas.openxmlformats.org/drawingml/2006/main">
               <a:ext uri="{FF2B5EF4-FFF2-40B4-BE49-F238E27FC236}">
-                <a16:creationId xmlns:a16="http://schemas.microsoft.com/office/drawing/2014/main" id="{D8602685-916C-4FED-BE37-E36EDCF32C72}"/>
+                <a16:creationId xmlns:a16="http://schemas.microsoft.com/office/drawing/2014/main" id="{3B1A344D-F3D5-43A3-9529-F288F5480C36}"/>
               </a:ext>
             </a:extLst>
           </p:cNvPr>
@@ -2959,6 +3111,7 @@
           <a:lstStyle xmlns:a="http://schemas.openxmlformats.org/drawingml/2006/main"/>
           <a:p xmlns:a="http://schemas.openxmlformats.org/drawingml/2006/main">
             <a:pPr>
+              <a:buNone/>
               <a:defRPr sz="1575" b="1">
                 <a:solidFill>
                   <a:srgbClr val="263C3A"/>
@@ -2987,7 +3140,7 @@
           <p:cNvPr id="5" name="">
             <a:extLst xmlns:a="http://schemas.openxmlformats.org/drawingml/2006/main">
               <a:ext uri="{FF2B5EF4-FFF2-40B4-BE49-F238E27FC236}">
-                <a16:creationId xmlns:a16="http://schemas.microsoft.com/office/drawing/2014/main" id="{5FD698EE-4C0D-472A-A3A5-DA437A6CBAE5}"/>
+                <a16:creationId xmlns:a16="http://schemas.microsoft.com/office/drawing/2014/main" id="{36600F1A-10DB-4541-A43D-85017C205ACE}"/>
               </a:ext>
             </a:extLst>
           </p:cNvPr>
@@ -3016,6 +3169,7 @@
           <a:lstStyle xmlns:a="http://schemas.openxmlformats.org/drawingml/2006/main"/>
           <a:p xmlns:a="http://schemas.openxmlformats.org/drawingml/2006/main">
             <a:pPr>
+              <a:buNone/>
               <a:defRPr sz="1575" b="1">
                 <a:solidFill>
                   <a:srgbClr val="263C3A"/>
@@ -3044,7 +3198,7 @@
           <p:cNvPr id="6" name="">
             <a:extLst xmlns:a="http://schemas.openxmlformats.org/drawingml/2006/main">
               <a:ext uri="{FF2B5EF4-FFF2-40B4-BE49-F238E27FC236}">
-                <a16:creationId xmlns:a16="http://schemas.microsoft.com/office/drawing/2014/main" id="{0C5FF755-5C7E-416B-8181-9E0A6F0E0EFF}"/>
+                <a16:creationId xmlns:a16="http://schemas.microsoft.com/office/drawing/2014/main" id="{3462DD68-E232-4DA2-B0C8-90A84549A698}"/>
               </a:ext>
             </a:extLst>
           </p:cNvPr>
@@ -3076,7 +3230,7 @@
           <p:cNvPr id="7" name="">
             <a:extLst xmlns:a="http://schemas.openxmlformats.org/drawingml/2006/main">
               <a:ext uri="{FF2B5EF4-FFF2-40B4-BE49-F238E27FC236}">
-                <a16:creationId xmlns:a16="http://schemas.microsoft.com/office/drawing/2014/main" id="{DA8A93C3-181A-459F-942C-FBFB73F05776}"/>
+                <a16:creationId xmlns:a16="http://schemas.microsoft.com/office/drawing/2014/main" id="{3E69A39E-D0BF-4686-83BA-BEB817A7BA64}"/>
               </a:ext>
             </a:extLst>
           </p:cNvPr>
@@ -3105,6 +3259,7 @@
           <a:lstStyle xmlns:a="http://schemas.openxmlformats.org/drawingml/2006/main"/>
           <a:p xmlns:a="http://schemas.openxmlformats.org/drawingml/2006/main">
             <a:pPr>
+              <a:buNone/>
               <a:defRPr sz="1800" b="1">
                 <a:solidFill>
                   <a:srgbClr val="263C3A"/>
@@ -3133,7 +3288,7 @@
           <p:cNvPr id="8" name="">
             <a:extLst xmlns:a="http://schemas.openxmlformats.org/drawingml/2006/main">
               <a:ext uri="{FF2B5EF4-FFF2-40B4-BE49-F238E27FC236}">
-                <a16:creationId xmlns:a16="http://schemas.microsoft.com/office/drawing/2014/main" id="{64B59356-F015-4BCC-9588-5C81D84785C3}"/>
+                <a16:creationId xmlns:a16="http://schemas.microsoft.com/office/drawing/2014/main" id="{271AF18A-EA28-4FE8-A5BB-3030BB0E9C8C}"/>
               </a:ext>
             </a:extLst>
           </p:cNvPr>
@@ -3165,7 +3320,7 @@
           <p:cNvPr id="9" name="">
             <a:extLst xmlns:a="http://schemas.openxmlformats.org/drawingml/2006/main">
               <a:ext uri="{FF2B5EF4-FFF2-40B4-BE49-F238E27FC236}">
-                <a16:creationId xmlns:a16="http://schemas.microsoft.com/office/drawing/2014/main" id="{EB934425-AF44-41B4-88FB-40868170E07A}"/>
+                <a16:creationId xmlns:a16="http://schemas.microsoft.com/office/drawing/2014/main" id="{EDC2955B-3CD8-4CAA-B62B-813A907A5DCC}"/>
               </a:ext>
             </a:extLst>
           </p:cNvPr>
@@ -3194,6 +3349,7 @@
           <a:lstStyle xmlns:a="http://schemas.openxmlformats.org/drawingml/2006/main"/>
           <a:p xmlns:a="http://schemas.openxmlformats.org/drawingml/2006/main">
             <a:pPr>
+              <a:buNone/>
               <a:defRPr sz="1800" b="1">
                 <a:solidFill>
                   <a:srgbClr val="263C3A"/>
@@ -3222,7 +3378,7 @@
           <p:cNvPr id="10" name="">
             <a:extLst xmlns:a="http://schemas.openxmlformats.org/drawingml/2006/main">
               <a:ext uri="{FF2B5EF4-FFF2-40B4-BE49-F238E27FC236}">
-                <a16:creationId xmlns:a16="http://schemas.microsoft.com/office/drawing/2014/main" id="{1220789E-1DA4-40BC-89E8-3F5961AB5C0D}"/>
+                <a16:creationId xmlns:a16="http://schemas.microsoft.com/office/drawing/2014/main" id="{A5300841-C4C6-4FF2-B4AE-77E14C10E74C}"/>
               </a:ext>
             </a:extLst>
           </p:cNvPr>
@@ -3254,7 +3410,7 @@
           <p:cNvPr id="11" name="">
             <a:extLst xmlns:a="http://schemas.openxmlformats.org/drawingml/2006/main">
               <a:ext uri="{FF2B5EF4-FFF2-40B4-BE49-F238E27FC236}">
-                <a16:creationId xmlns:a16="http://schemas.microsoft.com/office/drawing/2014/main" id="{236C6B2C-AFBD-46BD-95CC-CCBF55CF9D4E}"/>
+                <a16:creationId xmlns:a16="http://schemas.microsoft.com/office/drawing/2014/main" id="{C0E9252F-6704-4904-9979-940409B9B6BE}"/>
               </a:ext>
             </a:extLst>
           </p:cNvPr>
@@ -3283,6 +3439,7 @@
           <a:lstStyle xmlns:a="http://schemas.openxmlformats.org/drawingml/2006/main"/>
           <a:p xmlns:a="http://schemas.openxmlformats.org/drawingml/2006/main">
             <a:pPr>
+              <a:buNone/>
               <a:defRPr sz="1800" b="1">
                 <a:solidFill>
                   <a:srgbClr val="263C3A"/>
@@ -3311,7 +3468,7 @@
           <p:cNvPr id="12" name="">
             <a:extLst xmlns:a="http://schemas.openxmlformats.org/drawingml/2006/main">
               <a:ext uri="{FF2B5EF4-FFF2-40B4-BE49-F238E27FC236}">
-                <a16:creationId xmlns:a16="http://schemas.microsoft.com/office/drawing/2014/main" id="{496BD1F6-BDDA-4041-9CFC-A489B6D5BC4C}"/>
+                <a16:creationId xmlns:a16="http://schemas.microsoft.com/office/drawing/2014/main" id="{A05C8D3F-359E-4D6C-AF5E-374914D89559}"/>
               </a:ext>
             </a:extLst>
           </p:cNvPr>
@@ -3341,7 +3498,7 @@
           <p:cNvPr id="13" name="">
             <a:extLst xmlns:a="http://schemas.openxmlformats.org/drawingml/2006/main">
               <a:ext uri="{FF2B5EF4-FFF2-40B4-BE49-F238E27FC236}">
-                <a16:creationId xmlns:a16="http://schemas.microsoft.com/office/drawing/2014/main" id="{005F5743-26D4-4452-A3EE-1CAC195657E5}"/>
+                <a16:creationId xmlns:a16="http://schemas.microsoft.com/office/drawing/2014/main" id="{E0EC067F-D638-479E-BE48-FF82009D16EF}"/>
               </a:ext>
             </a:extLst>
           </p:cNvPr>
@@ -3370,6 +3527,7 @@
           <a:lstStyle xmlns:a="http://schemas.openxmlformats.org/drawingml/2006/main"/>
           <a:p xmlns:a="http://schemas.openxmlformats.org/drawingml/2006/main">
             <a:pPr>
+              <a:buNone/>
               <a:defRPr sz="1650" b="0">
                 <a:solidFill>
                   <a:srgbClr val="687572"/>
@@ -3398,7 +3556,7 @@
           <p:cNvPr id="14" name="">
             <a:extLst xmlns:a="http://schemas.openxmlformats.org/drawingml/2006/main">
               <a:ext uri="{FF2B5EF4-FFF2-40B4-BE49-F238E27FC236}">
-                <a16:creationId xmlns:a16="http://schemas.microsoft.com/office/drawing/2014/main" id="{6DA3574D-6909-4F20-A6A2-EBF8B043F33F}"/>
+                <a16:creationId xmlns:a16="http://schemas.microsoft.com/office/drawing/2014/main" id="{D2CD1412-D497-4D11-A1D9-AD2C69FDB007}"/>
               </a:ext>
             </a:extLst>
           </p:cNvPr>
@@ -3427,6 +3585,7 @@
           <a:lstStyle xmlns:a="http://schemas.openxmlformats.org/drawingml/2006/main"/>
           <a:p xmlns:a="http://schemas.openxmlformats.org/drawingml/2006/main">
             <a:pPr>
+              <a:buNone/>
               <a:defRPr sz="1650" b="0">
                 <a:solidFill>
                   <a:srgbClr val="687572"/>
@@ -3450,10 +3609,79 @@
           </a:p>
         </p:txBody>
       </p:sp>
+      <p:sp>
+        <p:nvSpPr>
+          <p:cNvPr id="16" name="source-credit">
+            <a:extLst xmlns:a="http://schemas.openxmlformats.org/drawingml/2006/main">
+              <a:ext uri="{FF2B5EF4-FFF2-40B4-BE49-F238E27FC236}">
+                <a16:creationId xmlns:a16="http://schemas.microsoft.com/office/drawing/2014/main" id="{EFB6AC15-3AC2-4DD6-9C26-595A9A76506A}"/>
+              </a:ext>
+            </a:extLst>
+          </p:cNvPr>
+          <p:cNvSpPr>
+            <a:spLocks xmlns:a="http://schemas.openxmlformats.org/drawingml/2006/main" noGrp="1"/>
+          </p:cNvSpPr>
+          <p:nvPr/>
+        </p:nvSpPr>
+        <p:spPr>
+          <a:xfrm xmlns:a="http://schemas.openxmlformats.org/drawingml/2006/main">
+            <a:off x="609600" y="6591300"/>
+            <a:ext cx="10972800" cy="190500"/>
+          </a:xfrm>
+          <a:prstGeom xmlns:a="http://schemas.openxmlformats.org/drawingml/2006/main" prst="rect">
+            <a:avLst/>
+          </a:prstGeom>
+          <a:noFill xmlns:a="http://schemas.openxmlformats.org/drawingml/2006/main"/>
+          <a:ln xmlns:a="http://schemas.openxmlformats.org/drawingml/2006/main" w="0">
+            <a:noFill/>
+          </a:ln>
+        </p:spPr>
+        <p:txBody>
+          <a:bodyPr xmlns:a="http://schemas.openxmlformats.org/drawingml/2006/main" wrap="none" lIns="0" tIns="0" rIns="0" bIns="0" anchor="t">
+            <a:noAutofit/>
+          </a:bodyPr>
+          <a:lstStyle xmlns:a="http://schemas.openxmlformats.org/drawingml/2006/main"/>
+          <a:p xmlns:a="http://schemas.openxmlformats.org/drawingml/2006/main">
+            <a:pPr>
+              <a:defRPr sz="900">
+                <a:solidFill>
+                  <a:srgbClr val="687572"/>
+                </a:solidFill>
+                <a:latin typeface="DejaVu Sans"/>
+                <a:ea typeface="DejaVu Sans"/>
+                <a:cs typeface="DejaVu Sans"/>
+              </a:defRPr>
+            </a:pPr>
+            <a:r>
+              <a:rPr sz="900">
+                <a:solidFill>
+                  <a:srgbClr val="687572"/>
+                </a:solidFill>
+                <a:latin typeface="DejaVu Sans"/>
+                <a:ea typeface="DejaVu Sans"/>
+                <a:cs typeface="DejaVu Sans"/>
+              </a:rPr>
+              <a:t>Source: </a:t>
+            </a:r>
+            <a:r>
+              <a:rPr sz="900">
+                <a:solidFill>
+                  <a:srgbClr val="687572"/>
+                </a:solidFill>
+                <a:latin typeface="DejaVu Sans"/>
+                <a:ea typeface="DejaVu Sans"/>
+                <a:cs typeface="DejaVu Sans"/>
+                <a:hlinkClick xmlns:r="http://schemas.openxmlformats.org/officeDocument/2006/relationships" r:id="Rfbc425dca8484095"/>
+              </a:rPr>
+              <a:t>Judith C. Hochman &amp; Natalie Wexler — The Writing Revolution; Bradford Research School adaptation — original guidance</a:t>
+            </a:r>
+          </a:p>
+        </p:txBody>
+      </p:sp>
     </p:spTree>
     <p:extLst>
       <p:ext uri="{BB962C8B-B14F-4D97-AF65-F5344CB8AC3E}">
-        <p14:creationId xmlns:p14="http://schemas.microsoft.com/office/powerpoint/2010/main" val="1513921821"/>
+        <p14:creationId xmlns:p14="http://schemas.microsoft.com/office/powerpoint/2010/main" val="690623088"/>
       </p:ext>
     </p:extLst>
   </p:cSld>

</xml_diff>